<commit_message>
Fix SAM report issues in steps 4, 6, 7, 13, 15, 16
Co-Authored-By: Claude Opus 5.5 <noreply@anthropic.com>
Claude-Session: https://claude.ai/code/session_019vWsQ7cqZqMPUmvYcgVUbt
</commit_message>
<xml_diff>
--- a/NP_PPT19_2a_BraedenMcCrea_2.pptx
+++ b/NP_PPT19_2a_BraedenMcCrea_2.pptx
@@ -1,22 +1,22 @@
 
 <file path=ppt/presentation.xml><?xml version="1.0" encoding="utf-8"?>
-<p:presentation xmlns:a="http://schemas.openxmlformats.org/drawingml/2006/main" xmlns:r="http://schemas.openxmlformats.org/officeDocument/2006/relationships" xmlns:p="http://schemas.openxmlformats.org/presentationml/2006/main" saveSubsetFonts="1">
+<p:presentation xmlns:a="http://schemas.openxmlformats.org/drawingml/2006/main" xmlns:r="http://schemas.openxmlformats.org/officeDocument/2006/relationships" xmlns:p="http://schemas.openxmlformats.org/presentationml/2006/main" saveSubsetFonts="1" showSpecialPlsOnTitleSld="0">
   <p:sldMasterIdLst>
-    <p:sldMasterId id="2147483648" r:id="rId1"/>
+    <p:sldMasterId id="2147483648" r:id="rId2"/>
   </p:sldMasterIdLst>
   <p:notesMasterIdLst>
-    <p:notesMasterId r:id="rId11"/>
+    <p:notesMasterId r:id="rId12"/>
   </p:notesMasterIdLst>
   <p:sldIdLst>
-    <p:sldId id="256" r:id="rId2"/>
-    <p:sldId id="257" r:id="rId3"/>
-    <p:sldId id="258" r:id="rId4"/>
-    <p:sldId id="265" r:id="rId5"/>
-    <p:sldId id="260" r:id="rId6"/>
-    <p:sldId id="261" r:id="rId7"/>
-    <p:sldId id="262" r:id="rId8"/>
-    <p:sldId id="263" r:id="rId9"/>
-    <p:sldId id="264" r:id="rId10"/>
+    <p:sldId id="256" r:id="rId3"/>
+    <p:sldId id="257" r:id="rId4"/>
+    <p:sldId id="258" r:id="rId5"/>
+    <p:sldId id="265" r:id="rId6"/>
+    <p:sldId id="260" r:id="rId7"/>
+    <p:sldId id="261" r:id="rId8"/>
+    <p:sldId id="262" r:id="rId9"/>
+    <p:sldId id="263" r:id="rId10"/>
+    <p:sldId id="264" r:id="rId11"/>
   </p:sldIdLst>
   <p:sldSz cx="12192000" cy="6858000"/>
   <p:notesSz cx="6858000" cy="9144000"/>
@@ -217,7 +217,7 @@
           <a:p>
             <a:fld id="{19AF605E-FD5F-4AA7-A75A-50252E819AC0}" type="datetimeFigureOut">
               <a:rPr lang="en-US" smtClean="0"/>
-              <a:t>7/16/2018</a:t>
+              <a:t>10/13/26</a:t>
             </a:fld>
             <a:endParaRPr lang="en-US" dirty="0"/>
           </a:p>
@@ -638,7 +638,7 @@
           </a:lstStyle>
           <a:p>
             <a:r>
-              <a:rPr lang="en-US" smtClean="0"/>
+              <a:rPr lang="en-US"/>
               <a:t>Click to edit Master title style</a:t>
             </a:r>
             <a:endParaRPr/>
@@ -712,7 +712,7 @@
           </a:lstStyle>
           <a:p>
             <a:r>
-              <a:rPr lang="en-US" smtClean="0"/>
+              <a:rPr lang="en-US"/>
               <a:t>Click to edit Master subtitle style</a:t>
             </a:r>
             <a:endParaRPr/>
@@ -758,15 +758,7 @@
   <p:clrMapOvr>
     <a:masterClrMapping/>
   </p:clrMapOvr>
-  <mc:AlternateContent xmlns:mc="http://schemas.openxmlformats.org/markup-compatibility/2006">
-    <mc:Choice xmlns:p14="http://schemas.microsoft.com/office/powerpoint/2010/main" Requires="p14">
-      <p:transition p14:dur="0"/>
-    </mc:Choice>
-    <mc:Fallback>
-      <p:transition/>
-    </mc:Fallback>
-  </mc:AlternateContent>
-  <p:extLst mod="1">
+  <p:extLst>
     <p:ext uri="{DCECCB84-F9BA-43D5-87BE-67443E8EF086}">
       <p15:sldGuideLst xmlns:p15="http://schemas.microsoft.com/office/powerpoint/2012/main"/>
     </p:ext>
@@ -807,7 +799,7 @@
           <a:lstStyle/>
           <a:p>
             <a:r>
-              <a:rPr lang="en-US" smtClean="0"/>
+              <a:rPr lang="en-US"/>
               <a:t>Click to edit Master title style</a:t>
             </a:r>
             <a:endParaRPr/>
@@ -831,35 +823,35 @@
           <a:p>
             <a:pPr lvl="0"/>
             <a:r>
-              <a:rPr lang="en-US" smtClean="0"/>
+              <a:rPr lang="en-US"/>
               <a:t>Edit Master text styles</a:t>
             </a:r>
           </a:p>
           <a:p>
             <a:pPr lvl="1"/>
             <a:r>
-              <a:rPr lang="en-US" smtClean="0"/>
+              <a:rPr lang="en-US"/>
               <a:t>Second level</a:t>
             </a:r>
           </a:p>
           <a:p>
             <a:pPr lvl="2"/>
             <a:r>
-              <a:rPr lang="en-US" smtClean="0"/>
+              <a:rPr lang="en-US"/>
               <a:t>Third level</a:t>
             </a:r>
           </a:p>
           <a:p>
             <a:pPr lvl="3"/>
             <a:r>
-              <a:rPr lang="en-US" smtClean="0"/>
+              <a:rPr lang="en-US"/>
               <a:t>Fourth level</a:t>
             </a:r>
           </a:p>
           <a:p>
             <a:pPr lvl="4"/>
             <a:r>
-              <a:rPr lang="en-US" smtClean="0"/>
+              <a:rPr lang="en-US"/>
               <a:t>Fifth level</a:t>
             </a:r>
             <a:endParaRPr/>
@@ -902,7 +894,7 @@
           <a:p>
             <a:fld id="{37CC0096-1860-4642-9CD2-0079EA5E7CD1}" type="datetimeFigureOut">
               <a:rPr lang="en-US"/>
-              <a:t>5/13/2018</a:t>
+              <a:t>10/13/26</a:t>
             </a:fld>
             <a:endParaRPr/>
           </a:p>
@@ -941,14 +933,6 @@
   <p:clrMapOvr>
     <a:masterClrMapping/>
   </p:clrMapOvr>
-  <mc:AlternateContent xmlns:mc="http://schemas.openxmlformats.org/markup-compatibility/2006">
-    <mc:Choice xmlns:p14="http://schemas.microsoft.com/office/powerpoint/2010/main" Requires="p14">
-      <p:transition p14:dur="0"/>
-    </mc:Choice>
-    <mc:Fallback>
-      <p:transition/>
-    </mc:Fallback>
-  </mc:AlternateContent>
 </p:sldLayout>
 </file>
 
@@ -1047,7 +1031,7 @@
           <a:lstStyle/>
           <a:p>
             <a:r>
-              <a:rPr lang="en-US" smtClean="0"/>
+              <a:rPr lang="en-US"/>
               <a:t>Click to edit Master title style</a:t>
             </a:r>
             <a:endParaRPr/>
@@ -1076,35 +1060,35 @@
           <a:p>
             <a:pPr lvl="0"/>
             <a:r>
-              <a:rPr lang="en-US" smtClean="0"/>
+              <a:rPr lang="en-US"/>
               <a:t>Edit Master text styles</a:t>
             </a:r>
           </a:p>
           <a:p>
             <a:pPr lvl="1"/>
             <a:r>
-              <a:rPr lang="en-US" smtClean="0"/>
+              <a:rPr lang="en-US"/>
               <a:t>Second level</a:t>
             </a:r>
           </a:p>
           <a:p>
             <a:pPr lvl="2"/>
             <a:r>
-              <a:rPr lang="en-US" smtClean="0"/>
+              <a:rPr lang="en-US"/>
               <a:t>Third level</a:t>
             </a:r>
           </a:p>
           <a:p>
             <a:pPr lvl="3"/>
             <a:r>
-              <a:rPr lang="en-US" smtClean="0"/>
+              <a:rPr lang="en-US"/>
               <a:t>Fourth level</a:t>
             </a:r>
           </a:p>
           <a:p>
             <a:pPr lvl="4"/>
             <a:r>
-              <a:rPr lang="en-US" smtClean="0"/>
+              <a:rPr lang="en-US"/>
               <a:t>Fifth level</a:t>
             </a:r>
             <a:endParaRPr/>
@@ -1147,7 +1131,7 @@
           <a:p>
             <a:fld id="{37CC0096-1860-4642-9CD2-0079EA5E7CD1}" type="datetimeFigureOut">
               <a:rPr lang="en-US"/>
-              <a:t>5/13/2018</a:t>
+              <a:t>10/13/26</a:t>
             </a:fld>
             <a:endParaRPr/>
           </a:p>
@@ -1186,14 +1170,6 @@
   <p:clrMapOvr>
     <a:masterClrMapping/>
   </p:clrMapOvr>
-  <mc:AlternateContent xmlns:mc="http://schemas.openxmlformats.org/markup-compatibility/2006">
-    <mc:Choice xmlns:p14="http://schemas.microsoft.com/office/powerpoint/2010/main" Requires="p14">
-      <p:transition p14:dur="0"/>
-    </mc:Choice>
-    <mc:Fallback>
-      <p:transition/>
-    </mc:Fallback>
-  </mc:AlternateContent>
 </p:sldLayout>
 </file>
 
@@ -1230,7 +1206,7 @@
           <a:lstStyle/>
           <a:p>
             <a:r>
-              <a:rPr lang="en-US" smtClean="0"/>
+              <a:rPr lang="en-US"/>
               <a:t>Click to edit Master title style</a:t>
             </a:r>
             <a:endParaRPr/>
@@ -1258,35 +1234,35 @@
           <a:p>
             <a:pPr lvl="0"/>
             <a:r>
-              <a:rPr lang="en-US" smtClean="0"/>
+              <a:rPr lang="en-US"/>
               <a:t>Edit Master text styles</a:t>
             </a:r>
           </a:p>
           <a:p>
             <a:pPr lvl="1"/>
             <a:r>
-              <a:rPr lang="en-US" smtClean="0"/>
+              <a:rPr lang="en-US"/>
               <a:t>Second level</a:t>
             </a:r>
           </a:p>
           <a:p>
             <a:pPr lvl="2"/>
             <a:r>
-              <a:rPr lang="en-US" smtClean="0"/>
+              <a:rPr lang="en-US"/>
               <a:t>Third level</a:t>
             </a:r>
           </a:p>
           <a:p>
             <a:pPr lvl="3"/>
             <a:r>
-              <a:rPr lang="en-US" smtClean="0"/>
+              <a:rPr lang="en-US"/>
               <a:t>Fourth level</a:t>
             </a:r>
           </a:p>
           <a:p>
             <a:pPr lvl="4"/>
             <a:r>
-              <a:rPr lang="en-US" smtClean="0"/>
+              <a:rPr lang="en-US"/>
               <a:t>Fifth level</a:t>
             </a:r>
             <a:endParaRPr/>
@@ -1329,7 +1305,7 @@
           <a:p>
             <a:fld id="{37CC0096-1860-4642-9CD2-0079EA5E7CD1}" type="datetimeFigureOut">
               <a:rPr lang="en-US"/>
-              <a:t>5/13/2018</a:t>
+              <a:t>10/13/26</a:t>
             </a:fld>
             <a:endParaRPr/>
           </a:p>
@@ -1368,14 +1344,6 @@
   <p:clrMapOvr>
     <a:masterClrMapping/>
   </p:clrMapOvr>
-  <mc:AlternateContent xmlns:mc="http://schemas.openxmlformats.org/markup-compatibility/2006">
-    <mc:Choice xmlns:p14="http://schemas.microsoft.com/office/powerpoint/2010/main" Requires="p14">
-      <p:transition p14:dur="0"/>
-    </mc:Choice>
-    <mc:Fallback>
-      <p:transition/>
-    </mc:Fallback>
-  </mc:AlternateContent>
 </p:sldLayout>
 </file>
 
@@ -1503,7 +1471,7 @@
           </a:lstStyle>
           <a:p>
             <a:r>
-              <a:rPr lang="en-US" smtClean="0"/>
+              <a:rPr lang="en-US"/>
               <a:t>Click to edit Master title style</a:t>
             </a:r>
             <a:endParaRPr/>
@@ -1575,7 +1543,7 @@
           <a:p>
             <a:pPr lvl="0"/>
             <a:r>
-              <a:rPr lang="en-US" smtClean="0"/>
+              <a:rPr lang="en-US"/>
               <a:t>Edit Master text styles</a:t>
             </a:r>
           </a:p>
@@ -1591,14 +1559,6 @@
   <p:clrMapOvr>
     <a:masterClrMapping/>
   </p:clrMapOvr>
-  <mc:AlternateContent xmlns:mc="http://schemas.openxmlformats.org/markup-compatibility/2006">
-    <mc:Choice xmlns:p14="http://schemas.microsoft.com/office/powerpoint/2010/main" Requires="p14">
-      <p:transition p14:dur="0"/>
-    </mc:Choice>
-    <mc:Fallback>
-      <p:transition/>
-    </mc:Fallback>
-  </mc:AlternateContent>
 </p:sldLayout>
 </file>
 
@@ -1635,7 +1595,7 @@
           <a:lstStyle/>
           <a:p>
             <a:r>
-              <a:rPr lang="en-US" smtClean="0"/>
+              <a:rPr lang="en-US"/>
               <a:t>Click to edit Master title style</a:t>
             </a:r>
             <a:endParaRPr/>
@@ -1694,35 +1654,35 @@
           <a:p>
             <a:pPr lvl="0"/>
             <a:r>
-              <a:rPr lang="en-US" smtClean="0"/>
+              <a:rPr lang="en-US"/>
               <a:t>Edit Master text styles</a:t>
             </a:r>
           </a:p>
           <a:p>
             <a:pPr lvl="1"/>
             <a:r>
-              <a:rPr lang="en-US" smtClean="0"/>
+              <a:rPr lang="en-US"/>
               <a:t>Second level</a:t>
             </a:r>
           </a:p>
           <a:p>
             <a:pPr lvl="2"/>
             <a:r>
-              <a:rPr lang="en-US" smtClean="0"/>
+              <a:rPr lang="en-US"/>
               <a:t>Third level</a:t>
             </a:r>
           </a:p>
           <a:p>
             <a:pPr lvl="3"/>
             <a:r>
-              <a:rPr lang="en-US" smtClean="0"/>
+              <a:rPr lang="en-US"/>
               <a:t>Fourth level</a:t>
             </a:r>
           </a:p>
           <a:p>
             <a:pPr lvl="4"/>
             <a:r>
-              <a:rPr lang="en-US" smtClean="0"/>
+              <a:rPr lang="en-US"/>
               <a:t>Fifth level</a:t>
             </a:r>
             <a:endParaRPr/>
@@ -1781,35 +1741,35 @@
           <a:p>
             <a:pPr lvl="0"/>
             <a:r>
-              <a:rPr lang="en-US" smtClean="0"/>
+              <a:rPr lang="en-US"/>
               <a:t>Edit Master text styles</a:t>
             </a:r>
           </a:p>
           <a:p>
             <a:pPr lvl="1"/>
             <a:r>
-              <a:rPr lang="en-US" smtClean="0"/>
+              <a:rPr lang="en-US"/>
               <a:t>Second level</a:t>
             </a:r>
           </a:p>
           <a:p>
             <a:pPr lvl="2"/>
             <a:r>
-              <a:rPr lang="en-US" smtClean="0"/>
+              <a:rPr lang="en-US"/>
               <a:t>Third level</a:t>
             </a:r>
           </a:p>
           <a:p>
             <a:pPr lvl="3"/>
             <a:r>
-              <a:rPr lang="en-US" smtClean="0"/>
+              <a:rPr lang="en-US"/>
               <a:t>Fourth level</a:t>
             </a:r>
           </a:p>
           <a:p>
             <a:pPr lvl="4"/>
             <a:r>
-              <a:rPr lang="en-US" smtClean="0"/>
+              <a:rPr lang="en-US"/>
               <a:t>Fifth level</a:t>
             </a:r>
             <a:endParaRPr/>
@@ -1852,7 +1812,7 @@
           <a:p>
             <a:fld id="{37CC0096-1860-4642-9CD2-0079EA5E7CD1}" type="datetimeFigureOut">
               <a:rPr lang="en-US"/>
-              <a:t>5/13/2018</a:t>
+              <a:t>10/13/26</a:t>
             </a:fld>
             <a:endParaRPr/>
           </a:p>
@@ -1891,14 +1851,6 @@
   <p:clrMapOvr>
     <a:masterClrMapping/>
   </p:clrMapOvr>
-  <mc:AlternateContent xmlns:mc="http://schemas.openxmlformats.org/markup-compatibility/2006">
-    <mc:Choice xmlns:p14="http://schemas.microsoft.com/office/powerpoint/2010/main" Requires="p14">
-      <p:transition p14:dur="0"/>
-    </mc:Choice>
-    <mc:Fallback>
-      <p:transition/>
-    </mc:Fallback>
-  </mc:AlternateContent>
 </p:sldLayout>
 </file>
 
@@ -1935,7 +1887,7 @@
           <a:lstStyle/>
           <a:p>
             <a:r>
-              <a:rPr lang="en-US" smtClean="0"/>
+              <a:rPr lang="en-US"/>
               <a:t>Click to edit Master title style</a:t>
             </a:r>
             <a:endParaRPr/>
@@ -2010,7 +1962,7 @@
           <a:p>
             <a:pPr lvl="0"/>
             <a:r>
-              <a:rPr lang="en-US" smtClean="0"/>
+              <a:rPr lang="en-US"/>
               <a:t>Edit Master text styles</a:t>
             </a:r>
           </a:p>
@@ -2068,35 +2020,35 @@
           <a:p>
             <a:pPr lvl="0"/>
             <a:r>
-              <a:rPr lang="en-US" smtClean="0"/>
+              <a:rPr lang="en-US"/>
               <a:t>Edit Master text styles</a:t>
             </a:r>
           </a:p>
           <a:p>
             <a:pPr lvl="1"/>
             <a:r>
-              <a:rPr lang="en-US" smtClean="0"/>
+              <a:rPr lang="en-US"/>
               <a:t>Second level</a:t>
             </a:r>
           </a:p>
           <a:p>
             <a:pPr lvl="2"/>
             <a:r>
-              <a:rPr lang="en-US" smtClean="0"/>
+              <a:rPr lang="en-US"/>
               <a:t>Third level</a:t>
             </a:r>
           </a:p>
           <a:p>
             <a:pPr lvl="3"/>
             <a:r>
-              <a:rPr lang="en-US" smtClean="0"/>
+              <a:rPr lang="en-US"/>
               <a:t>Fourth level</a:t>
             </a:r>
           </a:p>
           <a:p>
             <a:pPr lvl="4"/>
             <a:r>
-              <a:rPr lang="en-US" smtClean="0"/>
+              <a:rPr lang="en-US"/>
               <a:t>Fifth level</a:t>
             </a:r>
             <a:endParaRPr/>
@@ -2171,7 +2123,7 @@
           <a:p>
             <a:pPr lvl="0"/>
             <a:r>
-              <a:rPr lang="en-US" smtClean="0"/>
+              <a:rPr lang="en-US"/>
               <a:t>Edit Master text styles</a:t>
             </a:r>
           </a:p>
@@ -2229,35 +2181,35 @@
           <a:p>
             <a:pPr lvl="0"/>
             <a:r>
-              <a:rPr lang="en-US" smtClean="0"/>
+              <a:rPr lang="en-US"/>
               <a:t>Edit Master text styles</a:t>
             </a:r>
           </a:p>
           <a:p>
             <a:pPr lvl="1"/>
             <a:r>
-              <a:rPr lang="en-US" smtClean="0"/>
+              <a:rPr lang="en-US"/>
               <a:t>Second level</a:t>
             </a:r>
           </a:p>
           <a:p>
             <a:pPr lvl="2"/>
             <a:r>
-              <a:rPr lang="en-US" smtClean="0"/>
+              <a:rPr lang="en-US"/>
               <a:t>Third level</a:t>
             </a:r>
           </a:p>
           <a:p>
             <a:pPr lvl="3"/>
             <a:r>
-              <a:rPr lang="en-US" smtClean="0"/>
+              <a:rPr lang="en-US"/>
               <a:t>Fourth level</a:t>
             </a:r>
           </a:p>
           <a:p>
             <a:pPr lvl="4"/>
             <a:r>
-              <a:rPr lang="en-US" smtClean="0"/>
+              <a:rPr lang="en-US"/>
               <a:t>Fifth level</a:t>
             </a:r>
             <a:endParaRPr/>
@@ -2300,7 +2252,7 @@
           <a:p>
             <a:fld id="{37CC0096-1860-4642-9CD2-0079EA5E7CD1}" type="datetimeFigureOut">
               <a:rPr lang="en-US"/>
-              <a:t>5/13/2018</a:t>
+              <a:t>10/13/26</a:t>
             </a:fld>
             <a:endParaRPr/>
           </a:p>
@@ -2339,14 +2291,6 @@
   <p:clrMapOvr>
     <a:masterClrMapping/>
   </p:clrMapOvr>
-  <mc:AlternateContent xmlns:mc="http://schemas.openxmlformats.org/markup-compatibility/2006">
-    <mc:Choice xmlns:p14="http://schemas.microsoft.com/office/powerpoint/2010/main" Requires="p14">
-      <p:transition p14:dur="0"/>
-    </mc:Choice>
-    <mc:Fallback>
-      <p:transition/>
-    </mc:Fallback>
-  </mc:AlternateContent>
 </p:sldLayout>
 </file>
 
@@ -2383,7 +2327,7 @@
           <a:lstStyle/>
           <a:p>
             <a:r>
-              <a:rPr lang="en-US" smtClean="0"/>
+              <a:rPr lang="en-US"/>
               <a:t>Click to edit Master title style</a:t>
             </a:r>
             <a:endParaRPr/>
@@ -2426,7 +2370,7 @@
           <a:p>
             <a:fld id="{37CC0096-1860-4642-9CD2-0079EA5E7CD1}" type="datetimeFigureOut">
               <a:rPr lang="en-US"/>
-              <a:t>5/13/2018</a:t>
+              <a:t>10/13/26</a:t>
             </a:fld>
             <a:endParaRPr/>
           </a:p>
@@ -2465,14 +2409,6 @@
   <p:clrMapOvr>
     <a:masterClrMapping/>
   </p:clrMapOvr>
-  <mc:AlternateContent xmlns:mc="http://schemas.openxmlformats.org/markup-compatibility/2006">
-    <mc:Choice xmlns:p14="http://schemas.microsoft.com/office/powerpoint/2010/main" Requires="p14">
-      <p:transition p14:dur="0"/>
-    </mc:Choice>
-    <mc:Fallback>
-      <p:transition/>
-    </mc:Fallback>
-  </mc:AlternateContent>
 </p:sldLayout>
 </file>
 
@@ -2529,7 +2465,7 @@
           <a:p>
             <a:fld id="{37CC0096-1860-4642-9CD2-0079EA5E7CD1}" type="datetimeFigureOut">
               <a:rPr lang="en-US"/>
-              <a:t>5/13/2018</a:t>
+              <a:t>10/13/26</a:t>
             </a:fld>
             <a:endParaRPr/>
           </a:p>
@@ -2568,14 +2504,6 @@
   <p:clrMapOvr>
     <a:masterClrMapping/>
   </p:clrMapOvr>
-  <mc:AlternateContent xmlns:mc="http://schemas.openxmlformats.org/markup-compatibility/2006">
-    <mc:Choice xmlns:p14="http://schemas.microsoft.com/office/powerpoint/2010/main" Requires="p14">
-      <p:transition p14:dur="0"/>
-    </mc:Choice>
-    <mc:Fallback>
-      <p:transition/>
-    </mc:Fallback>
-  </mc:AlternateContent>
 </p:sldLayout>
 </file>
 
@@ -2740,7 +2668,7 @@
           </a:lstStyle>
           <a:p>
             <a:r>
-              <a:rPr lang="en-US" smtClean="0"/>
+              <a:rPr lang="en-US"/>
               <a:t>Click to edit Master title style</a:t>
             </a:r>
             <a:endParaRPr/>
@@ -2799,35 +2727,35 @@
           <a:p>
             <a:pPr lvl="0"/>
             <a:r>
-              <a:rPr lang="en-US" smtClean="0"/>
+              <a:rPr lang="en-US"/>
               <a:t>Edit Master text styles</a:t>
             </a:r>
           </a:p>
           <a:p>
             <a:pPr lvl="1"/>
             <a:r>
-              <a:rPr lang="en-US" smtClean="0"/>
+              <a:rPr lang="en-US"/>
               <a:t>Second level</a:t>
             </a:r>
           </a:p>
           <a:p>
             <a:pPr lvl="2"/>
             <a:r>
-              <a:rPr lang="en-US" smtClean="0"/>
+              <a:rPr lang="en-US"/>
               <a:t>Third level</a:t>
             </a:r>
           </a:p>
           <a:p>
             <a:pPr lvl="3"/>
             <a:r>
-              <a:rPr lang="en-US" smtClean="0"/>
+              <a:rPr lang="en-US"/>
               <a:t>Fourth level</a:t>
             </a:r>
           </a:p>
           <a:p>
             <a:pPr lvl="4"/>
             <a:r>
-              <a:rPr lang="en-US" smtClean="0"/>
+              <a:rPr lang="en-US"/>
               <a:t>Fifth level</a:t>
             </a:r>
             <a:endParaRPr/>
@@ -2899,7 +2827,7 @@
           <a:p>
             <a:pPr lvl="0"/>
             <a:r>
-              <a:rPr lang="en-US" smtClean="0"/>
+              <a:rPr lang="en-US"/>
               <a:t>Edit Master text styles</a:t>
             </a:r>
           </a:p>
@@ -2915,14 +2843,6 @@
   <p:clrMapOvr>
     <a:masterClrMapping/>
   </p:clrMapOvr>
-  <mc:AlternateContent xmlns:mc="http://schemas.openxmlformats.org/markup-compatibility/2006">
-    <mc:Choice xmlns:p14="http://schemas.microsoft.com/office/powerpoint/2010/main" Requires="p14">
-      <p:transition p14:dur="0"/>
-    </mc:Choice>
-    <mc:Fallback>
-      <p:transition/>
-    </mc:Fallback>
-  </mc:AlternateContent>
 </p:sldLayout>
 </file>
 
@@ -3087,7 +3007,7 @@
           </a:lstStyle>
           <a:p>
             <a:r>
-              <a:rPr lang="en-US" smtClean="0"/>
+              <a:rPr lang="en-US"/>
               <a:t>Click to edit Master title style</a:t>
             </a:r>
             <a:endParaRPr/>
@@ -3154,7 +3074,7 @@
           </a:lstStyle>
           <a:p>
             <a:r>
-              <a:rPr lang="en-US" smtClean="0"/>
+              <a:rPr lang="en-US"/>
               <a:t>Click icon to add picture</a:t>
             </a:r>
             <a:endParaRPr dirty="0"/>
@@ -3224,7 +3144,7 @@
           <a:p>
             <a:pPr lvl="0"/>
             <a:r>
-              <a:rPr lang="en-US" smtClean="0"/>
+              <a:rPr lang="en-US"/>
               <a:t>Edit Master text styles</a:t>
             </a:r>
           </a:p>
@@ -3240,14 +3160,6 @@
   <p:clrMapOvr>
     <a:masterClrMapping/>
   </p:clrMapOvr>
-  <mc:AlternateContent xmlns:mc="http://schemas.openxmlformats.org/markup-compatibility/2006">
-    <mc:Choice xmlns:p14="http://schemas.microsoft.com/office/powerpoint/2010/main" Requires="p14">
-      <p:transition p14:dur="0"/>
-    </mc:Choice>
-    <mc:Fallback>
-      <p:transition/>
-    </mc:Fallback>
-  </mc:AlternateContent>
 </p:sldLayout>
 </file>
 
@@ -3368,7 +3280,7 @@
           <a:lstStyle/>
           <a:p>
             <a:r>
-              <a:rPr lang="en-US" smtClean="0"/>
+              <a:rPr lang="en-US"/>
               <a:t>Click to edit Master title style</a:t>
             </a:r>
             <a:endParaRPr dirty="0"/>
@@ -3402,35 +3314,35 @@
           <a:p>
             <a:pPr lvl="0"/>
             <a:r>
-              <a:rPr lang="en-US" smtClean="0"/>
+              <a:rPr lang="en-US"/>
               <a:t>Edit Master text styles</a:t>
             </a:r>
           </a:p>
           <a:p>
             <a:pPr lvl="1"/>
             <a:r>
-              <a:rPr lang="en-US" smtClean="0"/>
+              <a:rPr lang="en-US"/>
               <a:t>Second level</a:t>
             </a:r>
           </a:p>
           <a:p>
             <a:pPr lvl="2"/>
             <a:r>
-              <a:rPr lang="en-US" smtClean="0"/>
+              <a:rPr lang="en-US"/>
               <a:t>Third level</a:t>
             </a:r>
           </a:p>
           <a:p>
             <a:pPr lvl="3"/>
             <a:r>
-              <a:rPr lang="en-US" smtClean="0"/>
+              <a:rPr lang="en-US"/>
               <a:t>Fourth level</a:t>
             </a:r>
           </a:p>
           <a:p>
             <a:pPr lvl="4"/>
             <a:r>
-              <a:rPr lang="en-US" smtClean="0"/>
+              <a:rPr lang="en-US"/>
               <a:t>Fifth level</a:t>
             </a:r>
             <a:endParaRPr dirty="0"/>
@@ -3506,7 +3418,7 @@
             <a:fld id="{37CC0096-1860-4642-9CD2-0079EA5E7CD1}" type="datetimeFigureOut">
               <a:rPr lang="en-US" smtClean="0"/>
               <a:pPr/>
-              <a:t>5/13/2018</a:t>
+              <a:t>10/13/26</a:t>
             </a:fld>
             <a:endParaRPr lang="en-US" dirty="0"/>
           </a:p>
@@ -3573,14 +3485,6 @@
     <p:sldLayoutId id="2147483658" r:id="rId10"/>
     <p:sldLayoutId id="2147483659" r:id="rId11"/>
   </p:sldLayoutIdLst>
-  <mc:AlternateContent xmlns:mc="http://schemas.openxmlformats.org/markup-compatibility/2006">
-    <mc:Choice xmlns:p14="http://schemas.microsoft.com/office/powerpoint/2010/main" Requires="p14">
-      <p:transition p14:dur="0"/>
-    </mc:Choice>
-    <mc:Fallback>
-      <p:transition/>
-    </mc:Fallback>
-  </mc:AlternateContent>
   <p:txStyles>
     <p:titleStyle>
       <a:lvl1pPr algn="l" defTabSz="914400" rtl="0" eaLnBrk="1" latinLnBrk="0" hangingPunct="1">
@@ -3897,7 +3801,7 @@
       </a:lvl9pPr>
     </p:otherStyle>
   </p:txStyles>
-  <p:extLst mod="1">
+  <p:extLst>
     <p:ext uri="{27BBF7A9-308A-43DC-89C8-2F10F3537804}">
       <p15:sldGuideLst xmlns:p15="http://schemas.microsoft.com/office/powerpoint/2012/main">
         <p15:guide id="1" orient="horz" pos="2160">
@@ -3917,7 +3821,7 @@
 </file>
 
 <file path=ppt/slides/slide1.xml><?xml version="1.0" encoding="utf-8"?>
-<p:sld xmlns:a="http://schemas.openxmlformats.org/drawingml/2006/main" xmlns:r="http://schemas.openxmlformats.org/officeDocument/2006/relationships" xmlns:p="http://schemas.openxmlformats.org/presentationml/2006/main" xmlns:p14="http://schemas.microsoft.com/office/powerpoint/2010/main">
+<p:sld xmlns:a="http://schemas.openxmlformats.org/drawingml/2006/main" xmlns:r="http://schemas.openxmlformats.org/officeDocument/2006/relationships" xmlns:p="http://schemas.openxmlformats.org/presentationml/2006/main">
   <p:cSld>
     <p:spTree>
       <p:nvGrpSpPr>
@@ -3993,7 +3897,7 @@
         <p14:switch dir="r"/>
       </p:transition>
     </mc:Choice>
-    <mc:Fallback>
+    <mc:Fallback xmlns="">
       <p:transition spd="slow">
         <p:fade/>
       </p:transition>
@@ -4003,7 +3907,7 @@
 </file>
 
 <file path=ppt/slides/slide2.xml><?xml version="1.0" encoding="utf-8"?>
-<p:sld xmlns:a="http://schemas.openxmlformats.org/drawingml/2006/main" xmlns:r="http://schemas.openxmlformats.org/officeDocument/2006/relationships" xmlns:p="http://schemas.openxmlformats.org/presentationml/2006/main" xmlns:p14="http://schemas.microsoft.com/office/powerpoint/2010/main">
+<p:sld xmlns:a="http://schemas.openxmlformats.org/drawingml/2006/main" xmlns:r="http://schemas.openxmlformats.org/officeDocument/2006/relationships" xmlns:p="http://schemas.openxmlformats.org/presentationml/2006/main">
   <p:cSld>
     <p:spTree>
       <p:nvGrpSpPr>
@@ -4130,7 +4034,7 @@
           <a:p>
             <a:fld id="{87C5E4AA-B42B-43B4-9314-F26E32E97B8E}" type="datetime1">
               <a:rPr lang="en-US"/>
-              <a:t>10/13/2026</a:t>
+              <a:t>10/13/26</a:t>
             </a:fld>
             <a:endParaRPr lang="en-US" dirty="0"/>
           </a:p>
@@ -4155,7 +4059,6 @@
               <a:rPr lang="en-US" dirty="0"/>
               <a:t>Lifeline Medical</a:t>
             </a:r>
-            <a:endParaRPr lang="en-US" dirty="0"/>
           </a:p>
         </p:txBody>
       </p:sp>
@@ -4175,7 +4078,7 @@
         <p14:switch dir="r"/>
       </p:transition>
     </mc:Choice>
-    <mc:Fallback>
+    <mc:Fallback xmlns="">
       <p:transition spd="slow">
         <p:fade/>
       </p:transition>
@@ -4733,7 +4636,7 @@
 </file>
 
 <file path=ppt/slides/slide3.xml><?xml version="1.0" encoding="utf-8"?>
-<p:sld xmlns:a="http://schemas.openxmlformats.org/drawingml/2006/main" xmlns:r="http://schemas.openxmlformats.org/officeDocument/2006/relationships" xmlns:p="http://schemas.openxmlformats.org/presentationml/2006/main" xmlns:p14="http://schemas.microsoft.com/office/powerpoint/2010/main">
+<p:sld xmlns:a="http://schemas.openxmlformats.org/drawingml/2006/main" xmlns:r="http://schemas.openxmlformats.org/officeDocument/2006/relationships" xmlns:p="http://schemas.openxmlformats.org/presentationml/2006/main">
   <p:cSld>
     <p:spTree>
       <p:nvGrpSpPr>
@@ -4826,7 +4729,7 @@
         </p:nvSpPr>
         <p:spPr>
           <a:xfrm>
-            <a:off x="9296400" y="1825625"/>
+            <a:off x="9677400" y="1825625"/>
             <a:ext cx="2514600" cy="2514600"/>
           </a:xfrm>
           <a:prstGeom prst="ellipse">
@@ -4856,7 +4759,6 @@
               <a:rPr lang="en-US" dirty="0"/>
               <a:t>LMS Call Button</a:t>
             </a:r>
-            <a:endParaRPr lang="en-US" dirty="0"/>
           </a:p>
         </p:txBody>
       </p:sp>
@@ -4910,7 +4812,7 @@
           <a:p>
             <a:fld id="{87C5E4AA-B42B-43B4-9314-F26E32E97B8E}" type="datetime1">
               <a:rPr lang="en-US"/>
-              <a:t>10/13/2026</a:t>
+              <a:t>10/13/26</a:t>
             </a:fld>
             <a:endParaRPr lang="en-US" dirty="0"/>
           </a:p>
@@ -4935,7 +4837,6 @@
               <a:rPr lang="en-US" dirty="0"/>
               <a:t>Lifeline Medical</a:t>
             </a:r>
-            <a:endParaRPr lang="en-US" dirty="0"/>
           </a:p>
         </p:txBody>
       </p:sp>
@@ -4955,7 +4856,7 @@
         <p14:switch dir="r"/>
       </p:transition>
     </mc:Choice>
-    <mc:Fallback>
+    <mc:Fallback xmlns="">
       <p:transition spd="slow">
         <p:fade/>
       </p:transition>
@@ -4965,7 +4866,7 @@
 </file>
 
 <file path=ppt/slides/slide4.xml><?xml version="1.0" encoding="utf-8"?>
-<p:sld xmlns:a="http://schemas.openxmlformats.org/drawingml/2006/main" xmlns:r="http://schemas.openxmlformats.org/officeDocument/2006/relationships" xmlns:p="http://schemas.openxmlformats.org/presentationml/2006/main" xmlns:p14="http://schemas.microsoft.com/office/powerpoint/2010/main">
+<p:sld xmlns:a="http://schemas.openxmlformats.org/drawingml/2006/main" xmlns:r="http://schemas.openxmlformats.org/officeDocument/2006/relationships" xmlns:p="http://schemas.openxmlformats.org/presentationml/2006/main">
   <p:cSld>
     <p:spTree>
       <p:nvGrpSpPr>
@@ -5116,7 +5017,7 @@
         </p:nvSpPr>
         <p:spPr>
           <a:xfrm>
-            <a:off x="6705600" y="1975104"/>
+            <a:off x="7429500" y="1975104"/>
             <a:ext cx="914400" cy="914400"/>
           </a:xfrm>
           <a:prstGeom prst="rect">
@@ -5154,7 +5055,6 @@
               <a:rPr lang="en-US" dirty="0"/>
               <a:t>We are here!</a:t>
             </a:r>
-            <a:endParaRPr lang="en-US" dirty="0"/>
           </a:p>
         </p:txBody>
       </p:sp>
@@ -5175,7 +5075,7 @@
           <a:p>
             <a:fld id="{87C5E4AA-B42B-43B4-9314-F26E32E97B8E}" type="datetime1">
               <a:rPr lang="en-US" smtClean="0"/>
-              <a:t>7/16/2018</a:t>
+              <a:t>10/13/26</a:t>
             </a:fld>
             <a:endParaRPr lang="en-US" dirty="0"/>
           </a:p>
@@ -5200,7 +5100,6 @@
               <a:rPr lang="en-US" dirty="0"/>
               <a:t>Lifeline Medical</a:t>
             </a:r>
-            <a:endParaRPr lang="en-US" dirty="0"/>
           </a:p>
         </p:txBody>
       </p:sp>
@@ -5220,7 +5119,7 @@
         <p14:switch dir="r"/>
       </p:transition>
     </mc:Choice>
-    <mc:Fallback>
+    <mc:Fallback xmlns="">
       <p:transition spd="slow">
         <p:fade/>
       </p:transition>
@@ -5299,7 +5198,7 @@
 </file>
 
 <file path=ppt/slides/slide5.xml><?xml version="1.0" encoding="utf-8"?>
-<p:sld xmlns:a="http://schemas.openxmlformats.org/drawingml/2006/main" xmlns:r="http://schemas.openxmlformats.org/officeDocument/2006/relationships" xmlns:p="http://schemas.openxmlformats.org/presentationml/2006/main" xmlns:p14="http://schemas.microsoft.com/office/powerpoint/2010/main">
+<p:sld xmlns:a="http://schemas.openxmlformats.org/drawingml/2006/main" xmlns:r="http://schemas.openxmlformats.org/officeDocument/2006/relationships" xmlns:p="http://schemas.openxmlformats.org/presentationml/2006/main">
   <p:cSld>
     <p:spTree>
       <p:nvGrpSpPr>
@@ -5444,7 +5343,7 @@
           <a:p>
             <a:fld id="{87C5E4AA-B42B-43B4-9314-F26E32E97B8E}" type="datetime1">
               <a:rPr lang="en-US"/>
-              <a:t>10/13/2026</a:t>
+              <a:t>10/13/26</a:t>
             </a:fld>
             <a:endParaRPr lang="en-US" dirty="0"/>
           </a:p>
@@ -5469,7 +5368,6 @@
               <a:rPr lang="en-US" dirty="0"/>
               <a:t>Lifeline Medical</a:t>
             </a:r>
-            <a:endParaRPr lang="en-US" dirty="0"/>
           </a:p>
         </p:txBody>
       </p:sp>
@@ -5489,7 +5387,7 @@
         <p14:switch dir="r"/>
       </p:transition>
     </mc:Choice>
-    <mc:Fallback>
+    <mc:Fallback xmlns="">
       <p:transition spd="slow">
         <p:fade/>
       </p:transition>
@@ -5499,7 +5397,7 @@
 </file>
 
 <file path=ppt/slides/slide6.xml><?xml version="1.0" encoding="utf-8"?>
-<p:sld xmlns:a="http://schemas.openxmlformats.org/drawingml/2006/main" xmlns:r="http://schemas.openxmlformats.org/officeDocument/2006/relationships" xmlns:p="http://schemas.openxmlformats.org/presentationml/2006/main" xmlns:p14="http://schemas.microsoft.com/office/powerpoint/2010/main">
+<p:sld xmlns:a="http://schemas.openxmlformats.org/drawingml/2006/main" xmlns:r="http://schemas.openxmlformats.org/officeDocument/2006/relationships" xmlns:p="http://schemas.openxmlformats.org/presentationml/2006/main">
   <p:cSld>
     <p:spTree>
       <p:nvGrpSpPr>
@@ -5547,10 +5445,10 @@
           </p:cNvPicPr>
           <p:nvPr>
             <p:ph idx="1"/>
-            <a:videoFile r:link="rId3"/>
+            <a:videoFile r:link="rId2"/>
             <p:extLst>
               <p:ext uri="{DAA4B4D4-6D71-4841-9C94-3DE7FCFB9230}">
-                <p14:media xmlns:p14="http://schemas.microsoft.com/office/powerpoint/2010/main" r:embed="rId2"/>
+                <p14:media xmlns:p14="http://schemas.microsoft.com/office/powerpoint/2010/main" r:embed="rId1"/>
               </p:ext>
             </p:extLst>
           </p:nvPr>
@@ -5612,7 +5510,7 @@
           <a:p>
             <a:fld id="{87C5E4AA-B42B-43B4-9314-F26E32E97B8E}" type="datetime1">
               <a:rPr lang="en-US"/>
-              <a:t>10/13/2026</a:t>
+              <a:t>10/13/26</a:t>
             </a:fld>
             <a:endParaRPr lang="en-US" dirty="0"/>
           </a:p>
@@ -5642,7 +5540,6 @@
               <a:rPr lang="en-US" dirty="0"/>
               <a:t>Lifeline Medical</a:t>
             </a:r>
-            <a:endParaRPr lang="en-US" dirty="0"/>
           </a:p>
         </p:txBody>
       </p:sp>
@@ -5662,7 +5559,7 @@
         <p14:switch dir="r"/>
       </p:transition>
     </mc:Choice>
-    <mc:Fallback>
+    <mc:Fallback xmlns="">
       <p:transition spd="slow">
         <p:fade/>
       </p:transition>
@@ -5752,7 +5649,7 @@
 </file>
 
 <file path=ppt/slides/slide7.xml><?xml version="1.0" encoding="utf-8"?>
-<p:sld xmlns:a="http://schemas.openxmlformats.org/drawingml/2006/main" xmlns:r="http://schemas.openxmlformats.org/officeDocument/2006/relationships" xmlns:p="http://schemas.openxmlformats.org/presentationml/2006/main" xmlns:p14="http://schemas.microsoft.com/office/powerpoint/2010/main">
+<p:sld xmlns:a="http://schemas.openxmlformats.org/drawingml/2006/main" xmlns:r="http://schemas.openxmlformats.org/officeDocument/2006/relationships" xmlns:p="http://schemas.openxmlformats.org/presentationml/2006/main">
   <p:cSld>
     <p:spTree>
       <p:nvGrpSpPr>
@@ -5811,8 +5708,20 @@
                 <a:tableStyleId>{5C22544A-7EE6-4342-B048-85BDC9FD1C3A}</a:tableStyleId>
               </a:tblPr>
               <a:tblGrid>
-                <a:gridCol w="4572000"/>
-                <a:gridCol w="4572000"/>
+                <a:gridCol w="4572000">
+                  <a:extLst>
+                    <a:ext uri="{9D8B030D-6E8A-4147-A177-3AD203B41FA5}">
+                      <a16:colId xmlns:a16="http://schemas.microsoft.com/office/drawing/2014/main" val="20000"/>
+                    </a:ext>
+                  </a:extLst>
+                </a:gridCol>
+                <a:gridCol w="4572000">
+                  <a:extLst>
+                    <a:ext uri="{9D8B030D-6E8A-4147-A177-3AD203B41FA5}">
+                      <a16:colId xmlns:a16="http://schemas.microsoft.com/office/drawing/2014/main" val="20001"/>
+                    </a:ext>
+                  </a:extLst>
+                </a:gridCol>
               </a:tblGrid>
               <a:tr h="370840">
                 <a:tc>
@@ -5841,6 +5750,11 @@
                   </a:txBody>
                   <a:tcPr/>
                 </a:tc>
+                <a:extLst>
+                  <a:ext uri="{0D108BD9-81ED-4DB2-BD59-A6C34878D82A}">
+                    <a16:rowId xmlns:a16="http://schemas.microsoft.com/office/drawing/2014/main" val="10000"/>
+                  </a:ext>
+                </a:extLst>
               </a:tr>
               <a:tr h="370840">
                 <a:tc>
@@ -5869,6 +5783,11 @@
                   </a:txBody>
                   <a:tcPr/>
                 </a:tc>
+                <a:extLst>
+                  <a:ext uri="{0D108BD9-81ED-4DB2-BD59-A6C34878D82A}">
+                    <a16:rowId xmlns:a16="http://schemas.microsoft.com/office/drawing/2014/main" val="10001"/>
+                  </a:ext>
+                </a:extLst>
               </a:tr>
               <a:tr h="370840">
                 <a:tc>
@@ -5897,6 +5816,11 @@
                   </a:txBody>
                   <a:tcPr/>
                 </a:tc>
+                <a:extLst>
+                  <a:ext uri="{0D108BD9-81ED-4DB2-BD59-A6C34878D82A}">
+                    <a16:rowId xmlns:a16="http://schemas.microsoft.com/office/drawing/2014/main" val="10002"/>
+                  </a:ext>
+                </a:extLst>
               </a:tr>
               <a:tr h="370840">
                 <a:tc>
@@ -5925,6 +5849,11 @@
                   </a:txBody>
                   <a:tcPr/>
                 </a:tc>
+                <a:extLst>
+                  <a:ext uri="{0D108BD9-81ED-4DB2-BD59-A6C34878D82A}">
+                    <a16:rowId xmlns:a16="http://schemas.microsoft.com/office/drawing/2014/main" val="10003"/>
+                  </a:ext>
+                </a:extLst>
               </a:tr>
             </a:tbl>
           </a:graphicData>
@@ -5947,7 +5876,7 @@
           <a:p>
             <a:fld id="{87C5E4AA-B42B-43B4-9314-F26E32E97B8E}" type="datetime1">
               <a:rPr lang="en-US"/>
-              <a:t>10/13/2026</a:t>
+              <a:t>10/13/26</a:t>
             </a:fld>
             <a:endParaRPr lang="en-US" dirty="0"/>
           </a:p>
@@ -5972,7 +5901,6 @@
               <a:rPr lang="en-US" dirty="0"/>
               <a:t>Lifeline Medical</a:t>
             </a:r>
-            <a:endParaRPr lang="en-US" dirty="0"/>
           </a:p>
         </p:txBody>
       </p:sp>
@@ -5992,7 +5920,7 @@
         <p14:switch dir="r"/>
       </p:transition>
     </mc:Choice>
-    <mc:Fallback>
+    <mc:Fallback xmlns="">
       <p:transition spd="slow">
         <p:fade/>
       </p:transition>
@@ -6002,7 +5930,7 @@
 </file>
 
 <file path=ppt/slides/slide8.xml><?xml version="1.0" encoding="utf-8"?>
-<p:sld xmlns:a="http://schemas.openxmlformats.org/drawingml/2006/main" xmlns:r="http://schemas.openxmlformats.org/officeDocument/2006/relationships" xmlns:p="http://schemas.openxmlformats.org/presentationml/2006/main" xmlns:p14="http://schemas.microsoft.com/office/powerpoint/2010/main">
+<p:sld xmlns:a="http://schemas.openxmlformats.org/drawingml/2006/main" xmlns:r="http://schemas.openxmlformats.org/officeDocument/2006/relationships" xmlns:p="http://schemas.openxmlformats.org/presentationml/2006/main">
   <p:cSld>
     <p:spTree>
       <p:nvGrpSpPr>
@@ -6328,7 +6256,7 @@
           <a:p>
             <a:fld id="{87C5E4AA-B42B-43B4-9314-F26E32E97B8E}" type="datetime1">
               <a:rPr lang="en-US"/>
-              <a:t>10/13/2026</a:t>
+              <a:t>10/13/26</a:t>
             </a:fld>
             <a:endParaRPr lang="en-US" dirty="0"/>
           </a:p>
@@ -6353,7 +6281,6 @@
               <a:rPr lang="en-US" dirty="0"/>
               <a:t>Lifeline Medical</a:t>
             </a:r>
-            <a:endParaRPr lang="en-US" dirty="0"/>
           </a:p>
         </p:txBody>
       </p:sp>
@@ -6373,7 +6300,7 @@
         <p14:switch dir="r"/>
       </p:transition>
     </mc:Choice>
-    <mc:Fallback>
+    <mc:Fallback xmlns="">
       <p:transition spd="slow">
         <p:fade/>
       </p:transition>
@@ -6383,7 +6310,7 @@
 </file>
 
 <file path=ppt/slides/slide9.xml><?xml version="1.0" encoding="utf-8"?>
-<p:sld xmlns:a="http://schemas.openxmlformats.org/drawingml/2006/main" xmlns:r="http://schemas.openxmlformats.org/officeDocument/2006/relationships" xmlns:p="http://schemas.openxmlformats.org/presentationml/2006/main" xmlns:p14="http://schemas.microsoft.com/office/powerpoint/2010/main">
+<p:sld xmlns:a="http://schemas.openxmlformats.org/drawingml/2006/main" xmlns:r="http://schemas.openxmlformats.org/officeDocument/2006/relationships" xmlns:p="http://schemas.openxmlformats.org/presentationml/2006/main">
   <p:cSld>
     <p:spTree>
       <p:nvGrpSpPr>
@@ -6530,7 +6457,7 @@
             <a:avLst/>
           </a:prstGeom>
           <a:effectLst>
-            <a:softEdge rad="112500"/>
+            <a:softEdge rad="63500"/>
           </a:effectLst>
         </p:spPr>
       </p:pic>
@@ -6551,7 +6478,7 @@
           <a:p>
             <a:fld id="{87C5E4AA-B42B-43B4-9314-F26E32E97B8E}" type="datetime1">
               <a:rPr lang="en-US"/>
-              <a:t>10/13/2026</a:t>
+              <a:t>10/13/26</a:t>
             </a:fld>
             <a:endParaRPr lang="en-US" dirty="0"/>
           </a:p>
@@ -6576,7 +6503,6 @@
               <a:rPr lang="en-US" dirty="0"/>
               <a:t>Lifeline Medical</a:t>
             </a:r>
-            <a:endParaRPr lang="en-US" dirty="0"/>
           </a:p>
         </p:txBody>
       </p:sp>
@@ -6593,10 +6519,10 @@
   <mc:AlternateContent xmlns:mc="http://schemas.openxmlformats.org/markup-compatibility/2006" xmlns:p14="http://schemas.microsoft.com/office/powerpoint/2010/main">
     <mc:Choice Requires="p14">
       <p:transition spd="slow" p14:dur="1750">
-        <p14:ferris dir="l"/>
+        <p14:ferris dir="r"/>
       </p:transition>
     </mc:Choice>
-    <mc:Fallback>
+    <mc:Fallback xmlns="">
       <p:transition spd="slow">
         <p:fade/>
       </p:transition>
@@ -7135,7 +7061,7 @@
 </file>
 
 <file path=customXml/itemProps1.xml><?xml version="1.0" encoding="utf-8"?>
-<ds:datastoreItem xmlns:ds="http://schemas.openxmlformats.org/officeDocument/2006/customXml" ds:itemID="{6e44fd94-11cd-4aca-9924-1d6daf7b974b}">
+<ds:datastoreItem xmlns:ds="http://schemas.openxmlformats.org/officeDocument/2006/customXml" ds:itemID="{6E44FD94-11CD-4ACA-9924-1D6DAF7B974B}">
   <ds:schemaRefs>
     <ds:schemaRef ds:uri="http://tempuri.org/temp"/>
   </ds:schemaRefs>

</xml_diff>